<commit_message>
Package final demo and submission materials with verified sources
</commit_message>
<xml_diff>
--- a/submission/lotline-pitch.pptx
+++ b/submission/lotline-pitch.pptx
@@ -2,22 +2,22 @@
 <file path=ppt/presentation.xml><?xml version="1.0" encoding="utf-8"?>
 <p:presentation xmlns:p="http://schemas.openxmlformats.org/presentationml/2006/main">
   <p:sldMasterIdLst>
-    <p:sldMasterId xmlns:r="http://schemas.openxmlformats.org/officeDocument/2006/relationships" id="2147483648" r:id="Rbcf9f751c7554716"/>
+    <p:sldMasterId xmlns:r="http://schemas.openxmlformats.org/officeDocument/2006/relationships" id="2147483648" r:id="R669d71595d6d4195"/>
   </p:sldMasterIdLst>
   <p:notesMasterIdLst>
-    <p:notesMasterId xmlns:r="http://schemas.openxmlformats.org/officeDocument/2006/relationships" r:id="R97d90298e210479e"/>
+    <p:notesMasterId xmlns:r="http://schemas.openxmlformats.org/officeDocument/2006/relationships" r:id="R8f5bf4309c774de1"/>
   </p:notesMasterIdLst>
   <p:sldIdLst>
-    <p:sldId xmlns:r="http://schemas.openxmlformats.org/officeDocument/2006/relationships" id="256" r:id="R57552e89a604488a"/>
-    <p:sldId xmlns:r="http://schemas.openxmlformats.org/officeDocument/2006/relationships" id="257" r:id="R637db833b13740ce"/>
-    <p:sldId xmlns:r="http://schemas.openxmlformats.org/officeDocument/2006/relationships" id="258" r:id="R14e44cd41cf7449d"/>
-    <p:sldId xmlns:r="http://schemas.openxmlformats.org/officeDocument/2006/relationships" id="259" r:id="R056480ee6949405a"/>
-    <p:sldId xmlns:r="http://schemas.openxmlformats.org/officeDocument/2006/relationships" id="260" r:id="Rfe4600036e5e440e"/>
-    <p:sldId xmlns:r="http://schemas.openxmlformats.org/officeDocument/2006/relationships" id="261" r:id="Rfbdbefc494194ec9"/>
-    <p:sldId xmlns:r="http://schemas.openxmlformats.org/officeDocument/2006/relationships" id="262" r:id="R2db29f2b2d0b45b8"/>
-    <p:sldId xmlns:r="http://schemas.openxmlformats.org/officeDocument/2006/relationships" id="263" r:id="Ra407b85b9b1641f2"/>
-    <p:sldId xmlns:r="http://schemas.openxmlformats.org/officeDocument/2006/relationships" id="264" r:id="R99db206e607d43cb"/>
-    <p:sldId xmlns:r="http://schemas.openxmlformats.org/officeDocument/2006/relationships" id="265" r:id="R8f5af83247054a26"/>
+    <p:sldId xmlns:r="http://schemas.openxmlformats.org/officeDocument/2006/relationships" id="256" r:id="Rb36ae737843a4304"/>
+    <p:sldId xmlns:r="http://schemas.openxmlformats.org/officeDocument/2006/relationships" id="257" r:id="Rbb1145e6918745c4"/>
+    <p:sldId xmlns:r="http://schemas.openxmlformats.org/officeDocument/2006/relationships" id="258" r:id="R68525fcaacb04b13"/>
+    <p:sldId xmlns:r="http://schemas.openxmlformats.org/officeDocument/2006/relationships" id="259" r:id="Ra71e837085b34e33"/>
+    <p:sldId xmlns:r="http://schemas.openxmlformats.org/officeDocument/2006/relationships" id="260" r:id="R9f1b76f535974073"/>
+    <p:sldId xmlns:r="http://schemas.openxmlformats.org/officeDocument/2006/relationships" id="261" r:id="Rf994e92d708b48b5"/>
+    <p:sldId xmlns:r="http://schemas.openxmlformats.org/officeDocument/2006/relationships" id="262" r:id="Rd997be82fe734d7f"/>
+    <p:sldId xmlns:r="http://schemas.openxmlformats.org/officeDocument/2006/relationships" id="263" r:id="R6c7f8335a7024897"/>
+    <p:sldId xmlns:r="http://schemas.openxmlformats.org/officeDocument/2006/relationships" id="264" r:id="R8af80d676c544b7a"/>
+    <p:sldId xmlns:r="http://schemas.openxmlformats.org/officeDocument/2006/relationships" id="265" r:id="R100d5a9c9c4343a5"/>
   </p:sldIdLst>
   <p:sldSz cx="12192000" cy="6858000"/>
   <p:notesSz cx="6858000" cy="9144000"/>
@@ -771,7 +771,7 @@
           </a:p>
           <a:p xmlns:a="http://schemas.openxmlformats.org/drawingml/2006/main">
             <a:r>
-              <a:t>Competition context: https://dev-home.ecri.org/blogs/ecri-blog/use-inventory-standardization-to-improve-your-safety-and-recall-alerts-program</a:t>
+              <a:t>Competition context: https://home.ecri.org/blogs/ecri-news/ecri-announces-recipients-of-2023-alerts-impact-award</a:t>
             </a:r>
           </a:p>
         </p:txBody>
@@ -981,12 +981,22 @@
           <a:lstStyle xmlns:a="http://schemas.openxmlformats.org/drawingml/2006/main"/>
           <a:p xmlns:a="http://schemas.openxmlformats.org/drawingml/2006/main">
             <a:r>
-              <a:t>There is established competition. ECRI offers alert workflow and inventory standardization. GHX offers inventory traceability and recall support. Generic alerts are already available. Our hypothesis is that small groups may value a simple response workspace fed by basic stock exports. A distributor could sponsor its customer sites. We would test 99 dollars monthly for a group with three sites, and 19 dollars per additional site. These are proposed test prices, not validated demand or revenue.</a:t>
-            </a:r>
-          </a:p>
-          <a:p xmlns:a="http://schemas.openxmlformats.org/drawingml/2006/main">
-            <a:r>
-              <a:t>ECRI: https://www.ecri.org.uk/wp-content/uploads/2021/04/ECRI-Technology-Decision-Support_v2.pdf</a:t>
+              <a:t>There is established competition. Staritas is the current home of the former ECRI recall-management business, spun out in April 2026. Its current site describes recall management and Alerts Workflow. Historical ECRI material documents inventory matching and response tracking, demonstrating that these capabilities predate Lotline. GHX offers inventory traceability and recall support; the cited brochure is European product material, not evidence of US pricing or a US customer contract. Generic alerts are already available. Our hypothesis is that small groups may value a simple response workspace fed by basic stock exports. A distributor could sponsor its customer sites. We would test 99 dollars monthly for a group with three sites, and 19 dollars per additional site. These are proposed test prices, not validated demand or revenue.</a:t>
+            </a:r>
+          </a:p>
+          <a:p xmlns:a="http://schemas.openxmlformats.org/drawingml/2006/main">
+            <a:r>
+              <a:t>Staritas current business: https://staritas.com/</a:t>
+            </a:r>
+          </a:p>
+          <a:p xmlns:a="http://schemas.openxmlformats.org/drawingml/2006/main">
+            <a:r>
+              <a:t>Official ECRI transition announcement: https://home.ecri.org/pages/announcement</a:t>
+            </a:r>
+          </a:p>
+          <a:p xmlns:a="http://schemas.openxmlformats.org/drawingml/2006/main">
+            <a:r>
+              <a:t>Historical ECRI workflow evidence: https://home.ecri.org/blogs/ecri-news/ecri-announces-recipients-of-2023-alerts-impact-award</a:t>
             </a:r>
           </a:p>
           <a:p xmlns:a="http://schemas.openxmlformats.org/drawingml/2006/main">
@@ -1204,7 +1214,7 @@
   </p:cSld>
   <p:clrMap bg1="lt1" tx1="dk1" bg2="lt2" tx2="dk2" accent1="accent1" accent2="accent2" accent3="accent3" accent4="accent4" accent5="accent5" accent6="accent6" hlink="hlink" folHlink="folHlink"/>
   <p:sldLayoutIdLst>
-    <p:sldLayoutId xmlns:r="http://schemas.openxmlformats.org/officeDocument/2006/relationships" id="2147483649" r:id="R9640ee22e4684825"/>
+    <p:sldLayoutId xmlns:r="http://schemas.openxmlformats.org/officeDocument/2006/relationships" id="2147483649" r:id="R80688cc5ae2e41c8"/>
   </p:sldLayoutIdLst>
   <p:txStyles>
     <p:titleStyle>
@@ -1755,7 +1765,7 @@
           <p:cNvPr id="7" name="">
             <a:extLst xmlns:a="http://schemas.openxmlformats.org/drawingml/2006/main">
               <a:ext uri="{FF2B5EF4-FFF2-40B4-BE49-F238E27FC236}">
-                <a16:creationId xmlns:a16="http://schemas.microsoft.com/office/drawing/2014/main" id="{DC68A053-3BBE-4B21-B367-BAAE9BDB2E79}"/>
+                <a16:creationId xmlns:a16="http://schemas.microsoft.com/office/drawing/2014/main" id="{F20C8830-3676-4E2B-8C03-FD668F364E2D}"/>
               </a:ext>
             </a:extLst>
           </p:cNvPr>
@@ -1812,7 +1822,7 @@
           <p:cNvPr id="2" name="">
             <a:extLst xmlns:a="http://schemas.openxmlformats.org/drawingml/2006/main">
               <a:ext uri="{FF2B5EF4-FFF2-40B4-BE49-F238E27FC236}">
-                <a16:creationId xmlns:a16="http://schemas.microsoft.com/office/drawing/2014/main" id="{0D6908D5-65FE-4BD6-A3D6-18166C8AA293}"/>
+                <a16:creationId xmlns:a16="http://schemas.microsoft.com/office/drawing/2014/main" id="{039E8663-2C6F-465E-B81F-CE2D7C1A0609}"/>
               </a:ext>
             </a:extLst>
           </p:cNvPr>
@@ -1869,7 +1879,7 @@
           <p:cNvPr id="3" name="">
             <a:extLst xmlns:a="http://schemas.openxmlformats.org/drawingml/2006/main">
               <a:ext uri="{FF2B5EF4-FFF2-40B4-BE49-F238E27FC236}">
-                <a16:creationId xmlns:a16="http://schemas.microsoft.com/office/drawing/2014/main" id="{8237F8DF-DA08-4AE8-A1B3-6C68CEFEF85F}"/>
+                <a16:creationId xmlns:a16="http://schemas.microsoft.com/office/drawing/2014/main" id="{CE5F6AF7-0A9B-4ADD-B12F-8A2381623C63}"/>
               </a:ext>
             </a:extLst>
           </p:cNvPr>
@@ -1949,7 +1959,7 @@
           <p:cNvPr id="4" name="">
             <a:extLst xmlns:a="http://schemas.openxmlformats.org/drawingml/2006/main">
               <a:ext uri="{FF2B5EF4-FFF2-40B4-BE49-F238E27FC236}">
-                <a16:creationId xmlns:a16="http://schemas.microsoft.com/office/drawing/2014/main" id="{E49D0C3A-EAB9-449F-B052-CF9426D59CE9}"/>
+                <a16:creationId xmlns:a16="http://schemas.microsoft.com/office/drawing/2014/main" id="{0ED66739-8317-427F-9D0D-22AE0E984923}"/>
               </a:ext>
             </a:extLst>
           </p:cNvPr>
@@ -2006,7 +2016,7 @@
           <p:cNvPr id="5" name="">
             <a:extLst xmlns:a="http://schemas.openxmlformats.org/drawingml/2006/main">
               <a:ext uri="{FF2B5EF4-FFF2-40B4-BE49-F238E27FC236}">
-                <a16:creationId xmlns:a16="http://schemas.microsoft.com/office/drawing/2014/main" id="{E5BB2470-1CA7-47CF-B342-4312497F2BFD}"/>
+                <a16:creationId xmlns:a16="http://schemas.microsoft.com/office/drawing/2014/main" id="{44435895-F340-455D-89AA-29CF7B52AA7E}"/>
               </a:ext>
             </a:extLst>
           </p:cNvPr>
@@ -2063,7 +2073,7 @@
           <p:cNvPr id="6" name="">
             <a:extLst xmlns:a="http://schemas.openxmlformats.org/drawingml/2006/main">
               <a:ext uri="{FF2B5EF4-FFF2-40B4-BE49-F238E27FC236}">
-                <a16:creationId xmlns:a16="http://schemas.microsoft.com/office/drawing/2014/main" id="{39E218D8-4D50-454A-985D-6415EAF7C39B}"/>
+                <a16:creationId xmlns:a16="http://schemas.microsoft.com/office/drawing/2014/main" id="{7BA7A701-31F3-4768-AD8A-BFA782DDFCBA}"/>
               </a:ext>
             </a:extLst>
           </p:cNvPr>
@@ -2118,7 +2128,7 @@
     </p:spTree>
     <p:extLst>
       <p:ext uri="{BB962C8B-B14F-4D97-AF65-F5344CB8AC3E}">
-        <p14:creationId xmlns:p14="http://schemas.microsoft.com/office/powerpoint/2010/main" val="1166809068"/>
+        <p14:creationId xmlns:p14="http://schemas.microsoft.com/office/powerpoint/2010/main" val="260776944"/>
       </p:ext>
     </p:extLst>
   </p:cSld>
@@ -2149,7 +2159,7 @@
           <p:cNvPr id="7" name="">
             <a:extLst xmlns:a="http://schemas.openxmlformats.org/drawingml/2006/main">
               <a:ext uri="{FF2B5EF4-FFF2-40B4-BE49-F238E27FC236}">
-                <a16:creationId xmlns:a16="http://schemas.microsoft.com/office/drawing/2014/main" id="{B44E8398-684B-45A9-843E-273A86A91605}"/>
+                <a16:creationId xmlns:a16="http://schemas.microsoft.com/office/drawing/2014/main" id="{8710C10D-6F5C-4004-8DA5-2C60011158A9}"/>
               </a:ext>
             </a:extLst>
           </p:cNvPr>
@@ -2206,7 +2216,7 @@
           <p:cNvPr id="2" name="">
             <a:extLst xmlns:a="http://schemas.openxmlformats.org/drawingml/2006/main">
               <a:ext uri="{FF2B5EF4-FFF2-40B4-BE49-F238E27FC236}">
-                <a16:creationId xmlns:a16="http://schemas.microsoft.com/office/drawing/2014/main" id="{476C2A5E-E139-431A-ADBF-7471AA08CDCB}"/>
+                <a16:creationId xmlns:a16="http://schemas.microsoft.com/office/drawing/2014/main" id="{25B706B4-CE70-4597-AA37-E12B75297304}"/>
               </a:ext>
             </a:extLst>
           </p:cNvPr>
@@ -2263,7 +2273,7 @@
           <p:cNvPr id="3" name="">
             <a:extLst xmlns:a="http://schemas.openxmlformats.org/drawingml/2006/main">
               <a:ext uri="{FF2B5EF4-FFF2-40B4-BE49-F238E27FC236}">
-                <a16:creationId xmlns:a16="http://schemas.microsoft.com/office/drawing/2014/main" id="{5BCEFA4D-3BC2-4B15-BA06-A88E8847BA6F}"/>
+                <a16:creationId xmlns:a16="http://schemas.microsoft.com/office/drawing/2014/main" id="{3452B9E4-FFA4-4E53-BBA7-30E1A7120B50}"/>
               </a:ext>
             </a:extLst>
           </p:cNvPr>
@@ -2320,7 +2330,7 @@
           <p:cNvPr id="4" name="">
             <a:extLst xmlns:a="http://schemas.openxmlformats.org/drawingml/2006/main">
               <a:ext uri="{FF2B5EF4-FFF2-40B4-BE49-F238E27FC236}">
-                <a16:creationId xmlns:a16="http://schemas.microsoft.com/office/drawing/2014/main" id="{1A7631FC-DD95-46B3-A319-BF776005621E}"/>
+                <a16:creationId xmlns:a16="http://schemas.microsoft.com/office/drawing/2014/main" id="{C49F399D-EA72-4F9D-BEDA-915B672C8996}"/>
               </a:ext>
             </a:extLst>
           </p:cNvPr>
@@ -2377,7 +2387,7 @@
           <p:cNvPr id="5" name="">
             <a:extLst xmlns:a="http://schemas.openxmlformats.org/drawingml/2006/main">
               <a:ext uri="{FF2B5EF4-FFF2-40B4-BE49-F238E27FC236}">
-                <a16:creationId xmlns:a16="http://schemas.microsoft.com/office/drawing/2014/main" id="{EB363682-C1E1-4D7E-94EA-D160E8078EAD}"/>
+                <a16:creationId xmlns:a16="http://schemas.microsoft.com/office/drawing/2014/main" id="{50C78C00-047C-404B-B0F8-346FA7899378}"/>
               </a:ext>
             </a:extLst>
           </p:cNvPr>
@@ -2480,7 +2490,7 @@
           <p:cNvPr id="6" name="">
             <a:extLst xmlns:a="http://schemas.openxmlformats.org/drawingml/2006/main">
               <a:ext uri="{FF2B5EF4-FFF2-40B4-BE49-F238E27FC236}">
-                <a16:creationId xmlns:a16="http://schemas.microsoft.com/office/drawing/2014/main" id="{1D269FEC-E98B-420F-AB5B-38BF274AEF69}"/>
+                <a16:creationId xmlns:a16="http://schemas.microsoft.com/office/drawing/2014/main" id="{7172C0A8-B34A-482D-86C9-10563871B9E0}"/>
               </a:ext>
             </a:extLst>
           </p:cNvPr>
@@ -2535,7 +2545,7 @@
     </p:spTree>
     <p:extLst>
       <p:ext uri="{BB962C8B-B14F-4D97-AF65-F5344CB8AC3E}">
-        <p14:creationId xmlns:p14="http://schemas.microsoft.com/office/powerpoint/2010/main" val="1973516124"/>
+        <p14:creationId xmlns:p14="http://schemas.microsoft.com/office/powerpoint/2010/main" val="1339250508"/>
       </p:ext>
     </p:extLst>
   </p:cSld>
@@ -2566,7 +2576,7 @@
           <p:cNvPr id="12" name="">
             <a:extLst xmlns:a="http://schemas.openxmlformats.org/drawingml/2006/main">
               <a:ext uri="{FF2B5EF4-FFF2-40B4-BE49-F238E27FC236}">
-                <a16:creationId xmlns:a16="http://schemas.microsoft.com/office/drawing/2014/main" id="{57F68F4E-8B83-43E9-9D69-D0AE09F51E80}"/>
+                <a16:creationId xmlns:a16="http://schemas.microsoft.com/office/drawing/2014/main" id="{5F974A22-C502-4748-A69E-22B388D08391}"/>
               </a:ext>
             </a:extLst>
           </p:cNvPr>
@@ -2623,7 +2633,7 @@
           <p:cNvPr id="2" name="">
             <a:extLst xmlns:a="http://schemas.openxmlformats.org/drawingml/2006/main">
               <a:ext uri="{FF2B5EF4-FFF2-40B4-BE49-F238E27FC236}">
-                <a16:creationId xmlns:a16="http://schemas.microsoft.com/office/drawing/2014/main" id="{F5D46C84-F529-45D0-B2F6-4B9FC1CB6934}"/>
+                <a16:creationId xmlns:a16="http://schemas.microsoft.com/office/drawing/2014/main" id="{6F36B780-70D3-4412-AB96-BFDE716C302C}"/>
               </a:ext>
             </a:extLst>
           </p:cNvPr>
@@ -2703,7 +2713,7 @@
           <p:cNvPr id="3" name="">
             <a:extLst xmlns:a="http://schemas.openxmlformats.org/drawingml/2006/main">
               <a:ext uri="{FF2B5EF4-FFF2-40B4-BE49-F238E27FC236}">
-                <a16:creationId xmlns:a16="http://schemas.microsoft.com/office/drawing/2014/main" id="{555E9DBB-079B-4F5D-873F-1A7915D8FC4E}"/>
+                <a16:creationId xmlns:a16="http://schemas.microsoft.com/office/drawing/2014/main" id="{79207BDC-D3A0-4200-B04D-004F1E4F69DA}"/>
               </a:ext>
             </a:extLst>
           </p:cNvPr>
@@ -2760,7 +2770,7 @@
           <p:cNvPr id="4" name="">
             <a:extLst xmlns:a="http://schemas.openxmlformats.org/drawingml/2006/main">
               <a:ext uri="{FF2B5EF4-FFF2-40B4-BE49-F238E27FC236}">
-                <a16:creationId xmlns:a16="http://schemas.microsoft.com/office/drawing/2014/main" id="{3C2D4DB4-536F-4DBF-9C8B-A7ECEAE1FE62}"/>
+                <a16:creationId xmlns:a16="http://schemas.microsoft.com/office/drawing/2014/main" id="{478C79B8-8A50-4FDC-AC08-35465E41824C}"/>
               </a:ext>
             </a:extLst>
           </p:cNvPr>
@@ -2863,7 +2873,7 @@
           <p:cNvPr id="5" name="">
             <a:extLst xmlns:a="http://schemas.openxmlformats.org/drawingml/2006/main">
               <a:ext uri="{FF2B5EF4-FFF2-40B4-BE49-F238E27FC236}">
-                <a16:creationId xmlns:a16="http://schemas.microsoft.com/office/drawing/2014/main" id="{DDC17439-D5AE-4276-BE43-51F1B3CBF2E8}"/>
+                <a16:creationId xmlns:a16="http://schemas.microsoft.com/office/drawing/2014/main" id="{F9625DBA-7F07-4110-AB17-9F9710A40DE2}"/>
               </a:ext>
             </a:extLst>
           </p:cNvPr>
@@ -2920,7 +2930,7 @@
           <p:cNvPr id="6" name="">
             <a:extLst xmlns:a="http://schemas.openxmlformats.org/drawingml/2006/main">
               <a:ext uri="{FF2B5EF4-FFF2-40B4-BE49-F238E27FC236}">
-                <a16:creationId xmlns:a16="http://schemas.microsoft.com/office/drawing/2014/main" id="{CECA1E29-C683-47A2-974E-AF300C8BD9E0}"/>
+                <a16:creationId xmlns:a16="http://schemas.microsoft.com/office/drawing/2014/main" id="{ACBB9413-50C0-43F8-8740-6465894F7CD6}"/>
               </a:ext>
             </a:extLst>
           </p:cNvPr>
@@ -2977,7 +2987,7 @@
           <p:cNvPr id="7" name="">
             <a:extLst xmlns:a="http://schemas.openxmlformats.org/drawingml/2006/main">
               <a:ext uri="{FF2B5EF4-FFF2-40B4-BE49-F238E27FC236}">
-                <a16:creationId xmlns:a16="http://schemas.microsoft.com/office/drawing/2014/main" id="{23EB0801-72B7-48DC-9B4A-9259F3AEEF3D}"/>
+                <a16:creationId xmlns:a16="http://schemas.microsoft.com/office/drawing/2014/main" id="{0CDB49B6-186A-4E8C-9FE5-BF8E064E8B29}"/>
               </a:ext>
             </a:extLst>
           </p:cNvPr>
@@ -3034,7 +3044,7 @@
           <p:cNvPr id="8" name="">
             <a:extLst xmlns:a="http://schemas.openxmlformats.org/drawingml/2006/main">
               <a:ext uri="{FF2B5EF4-FFF2-40B4-BE49-F238E27FC236}">
-                <a16:creationId xmlns:a16="http://schemas.microsoft.com/office/drawing/2014/main" id="{FD543D0B-588D-4443-93F7-AAF08E28ED8A}"/>
+                <a16:creationId xmlns:a16="http://schemas.microsoft.com/office/drawing/2014/main" id="{501403F3-7A82-4C37-9D04-06D3A8698D6A}"/>
               </a:ext>
             </a:extLst>
           </p:cNvPr>
@@ -3091,7 +3101,7 @@
           <p:cNvPr id="9" name="">
             <a:extLst xmlns:a="http://schemas.openxmlformats.org/drawingml/2006/main">
               <a:ext uri="{FF2B5EF4-FFF2-40B4-BE49-F238E27FC236}">
-                <a16:creationId xmlns:a16="http://schemas.microsoft.com/office/drawing/2014/main" id="{65FD1DEA-E1E7-42B5-AD68-28D248096D98}"/>
+                <a16:creationId xmlns:a16="http://schemas.microsoft.com/office/drawing/2014/main" id="{557E53E0-9EFA-4A66-8EED-A2F01BDB7A07}"/>
               </a:ext>
             </a:extLst>
           </p:cNvPr>
@@ -3148,7 +3158,7 @@
           <p:cNvPr id="10" name="">
             <a:extLst xmlns:a="http://schemas.openxmlformats.org/drawingml/2006/main">
               <a:ext uri="{FF2B5EF4-FFF2-40B4-BE49-F238E27FC236}">
-                <a16:creationId xmlns:a16="http://schemas.microsoft.com/office/drawing/2014/main" id="{44DC1FE7-4A67-4ED4-9409-B2733CB1BC87}"/>
+                <a16:creationId xmlns:a16="http://schemas.microsoft.com/office/drawing/2014/main" id="{D1FF5010-7955-46DA-8973-8BB331CD6755}"/>
               </a:ext>
             </a:extLst>
           </p:cNvPr>
@@ -3205,7 +3215,7 @@
           <p:cNvPr id="11" name="">
             <a:extLst xmlns:a="http://schemas.openxmlformats.org/drawingml/2006/main">
               <a:ext uri="{FF2B5EF4-FFF2-40B4-BE49-F238E27FC236}">
-                <a16:creationId xmlns:a16="http://schemas.microsoft.com/office/drawing/2014/main" id="{C5F6F0E6-D098-4F81-8AF2-CBF8D599D57A}"/>
+                <a16:creationId xmlns:a16="http://schemas.microsoft.com/office/drawing/2014/main" id="{1324DEE0-FF16-4295-B470-AD4D2F6DF23A}"/>
               </a:ext>
             </a:extLst>
           </p:cNvPr>
@@ -3251,7 +3261,7 @@
                 <a:latin typeface="Avenir"/>
                 <a:ea typeface="Avenir"/>
                 <a:cs typeface="Avenir"/>
-                <a:hlinkClick xmlns:r="http://schemas.openxmlformats.org/officeDocument/2006/relationships" r:id="R51cfa70551a748a5"/>
+                <a:hlinkClick xmlns:r="http://schemas.openxmlformats.org/officeDocument/2006/relationships" r:id="R8bc6736467d944c4"/>
               </a:rPr>
               <a:t>FDA recall Z-2614-2026</a:t>
             </a:r>
@@ -3272,7 +3282,7 @@
     </p:spTree>
     <p:extLst>
       <p:ext uri="{BB962C8B-B14F-4D97-AF65-F5344CB8AC3E}">
-        <p14:creationId xmlns:p14="http://schemas.microsoft.com/office/powerpoint/2010/main" val="1040447046"/>
+        <p14:creationId xmlns:p14="http://schemas.microsoft.com/office/powerpoint/2010/main" val="1043806544"/>
       </p:ext>
     </p:extLst>
   </p:cSld>
@@ -3303,7 +3313,7 @@
           <p:cNvPr id="8" name="">
             <a:extLst xmlns:a="http://schemas.openxmlformats.org/drawingml/2006/main">
               <a:ext uri="{FF2B5EF4-FFF2-40B4-BE49-F238E27FC236}">
-                <a16:creationId xmlns:a16="http://schemas.microsoft.com/office/drawing/2014/main" id="{F85B1B71-0059-49BF-A06E-188A0A5FAC2C}"/>
+                <a16:creationId xmlns:a16="http://schemas.microsoft.com/office/drawing/2014/main" id="{FEBA0CCC-77A9-4F30-98E2-669834854E5C}"/>
               </a:ext>
             </a:extLst>
           </p:cNvPr>
@@ -3360,7 +3370,7 @@
           <p:cNvPr id="2" name="">
             <a:extLst xmlns:a="http://schemas.openxmlformats.org/drawingml/2006/main">
               <a:ext uri="{FF2B5EF4-FFF2-40B4-BE49-F238E27FC236}">
-                <a16:creationId xmlns:a16="http://schemas.microsoft.com/office/drawing/2014/main" id="{EDC97867-474E-4B8A-A2CC-5A16781D7090}"/>
+                <a16:creationId xmlns:a16="http://schemas.microsoft.com/office/drawing/2014/main" id="{8C83C99D-6B0F-45AD-8B7B-F5F73F8D6DF5}"/>
               </a:ext>
             </a:extLst>
           </p:cNvPr>
@@ -3417,7 +3427,7 @@
           <p:cNvPr id="3" name="">
             <a:extLst xmlns:a="http://schemas.openxmlformats.org/drawingml/2006/main">
               <a:ext uri="{FF2B5EF4-FFF2-40B4-BE49-F238E27FC236}">
-                <a16:creationId xmlns:a16="http://schemas.microsoft.com/office/drawing/2014/main" id="{7D5191F6-DEA6-448A-95F7-0F750A64093F}"/>
+                <a16:creationId xmlns:a16="http://schemas.microsoft.com/office/drawing/2014/main" id="{E89E331C-0609-4C8B-A24B-84CA2FD0BA7A}"/>
               </a:ext>
             </a:extLst>
           </p:cNvPr>
@@ -3478,7 +3488,7 @@
           <p:nvPr/>
         </p:nvPicPr>
         <p:blipFill>
-          <a:blip xmlns:r="http://schemas.openxmlformats.org/officeDocument/2006/relationships" xmlns:a="http://schemas.openxmlformats.org/drawingml/2006/main" r:embed="Rbfd134f468b8451e"/>
+          <a:blip xmlns:r="http://schemas.openxmlformats.org/officeDocument/2006/relationships" xmlns:a="http://schemas.openxmlformats.org/drawingml/2006/main" r:embed="Rc3b85f40e7cb4386"/>
           <a:srcRect xmlns:a="http://schemas.openxmlformats.org/drawingml/2006/main" l="0" t="23824" r="0" b="59706"/>
           <a:stretch xmlns:a="http://schemas.openxmlformats.org/drawingml/2006/main">
             <a:fillRect l="0" t="0" r="0" b="0"/>
@@ -3499,7 +3509,7 @@
           <p:cNvPr id="5" name="">
             <a:extLst xmlns:a="http://schemas.openxmlformats.org/drawingml/2006/main">
               <a:ext uri="{FF2B5EF4-FFF2-40B4-BE49-F238E27FC236}">
-                <a16:creationId xmlns:a16="http://schemas.microsoft.com/office/drawing/2014/main" id="{37414F47-5E61-43AA-AA5C-F1F194E3AD3B}"/>
+                <a16:creationId xmlns:a16="http://schemas.microsoft.com/office/drawing/2014/main" id="{D33799C6-4351-4509-BDF8-3268E0959BF2}"/>
               </a:ext>
             </a:extLst>
           </p:cNvPr>
@@ -3556,7 +3566,7 @@
           <p:cNvPr id="6" name="">
             <a:extLst xmlns:a="http://schemas.openxmlformats.org/drawingml/2006/main">
               <a:ext uri="{FF2B5EF4-FFF2-40B4-BE49-F238E27FC236}">
-                <a16:creationId xmlns:a16="http://schemas.microsoft.com/office/drawing/2014/main" id="{20C1F83F-AFA4-4488-98CB-FCBD0E992C2D}"/>
+                <a16:creationId xmlns:a16="http://schemas.microsoft.com/office/drawing/2014/main" id="{B9360178-9664-4008-8DD6-E44CC5033D6F}"/>
               </a:ext>
             </a:extLst>
           </p:cNvPr>
@@ -3613,7 +3623,7 @@
           <p:cNvPr id="7" name="">
             <a:extLst xmlns:a="http://schemas.openxmlformats.org/drawingml/2006/main">
               <a:ext uri="{FF2B5EF4-FFF2-40B4-BE49-F238E27FC236}">
-                <a16:creationId xmlns:a16="http://schemas.microsoft.com/office/drawing/2014/main" id="{A45088EA-6E59-4E29-965B-0204F9864F36}"/>
+                <a16:creationId xmlns:a16="http://schemas.microsoft.com/office/drawing/2014/main" id="{C7D33FC6-E393-4230-B445-28B10671D363}"/>
               </a:ext>
             </a:extLst>
           </p:cNvPr>
@@ -3668,7 +3678,7 @@
     </p:spTree>
     <p:extLst>
       <p:ext uri="{BB962C8B-B14F-4D97-AF65-F5344CB8AC3E}">
-        <p14:creationId xmlns:p14="http://schemas.microsoft.com/office/powerpoint/2010/main" val="1861968426"/>
+        <p14:creationId xmlns:p14="http://schemas.microsoft.com/office/powerpoint/2010/main" val="1458930893"/>
       </p:ext>
     </p:extLst>
   </p:cSld>
@@ -3699,7 +3709,7 @@
           <p:cNvPr id="6" name="">
             <a:extLst xmlns:a="http://schemas.openxmlformats.org/drawingml/2006/main">
               <a:ext uri="{FF2B5EF4-FFF2-40B4-BE49-F238E27FC236}">
-                <a16:creationId xmlns:a16="http://schemas.microsoft.com/office/drawing/2014/main" id="{6791AAF7-2CB6-4B8B-8A29-F9E2582784E4}"/>
+                <a16:creationId xmlns:a16="http://schemas.microsoft.com/office/drawing/2014/main" id="{34DB8240-A9B6-4433-A9C9-260B2F021AD1}"/>
               </a:ext>
             </a:extLst>
           </p:cNvPr>
@@ -3756,7 +3766,7 @@
           <p:cNvPr id="2" name="">
             <a:extLst xmlns:a="http://schemas.openxmlformats.org/drawingml/2006/main">
               <a:ext uri="{FF2B5EF4-FFF2-40B4-BE49-F238E27FC236}">
-                <a16:creationId xmlns:a16="http://schemas.microsoft.com/office/drawing/2014/main" id="{A3038DDD-2F80-4D16-A2DC-AC21B3B8365A}"/>
+                <a16:creationId xmlns:a16="http://schemas.microsoft.com/office/drawing/2014/main" id="{C484A341-655C-4622-AF9B-5EEDB42CEEA6}"/>
               </a:ext>
             </a:extLst>
           </p:cNvPr>
@@ -3813,7 +3823,7 @@
           <p:cNvPr id="3" name="">
             <a:extLst xmlns:a="http://schemas.openxmlformats.org/drawingml/2006/main">
               <a:ext uri="{FF2B5EF4-FFF2-40B4-BE49-F238E27FC236}">
-                <a16:creationId xmlns:a16="http://schemas.microsoft.com/office/drawing/2014/main" id="{8F073ACC-3490-4738-A16C-89C04BF5F96B}"/>
+                <a16:creationId xmlns:a16="http://schemas.microsoft.com/office/drawing/2014/main" id="{DA37D5E1-F7B2-40B6-AD6A-227391B5253A}"/>
               </a:ext>
             </a:extLst>
           </p:cNvPr>
@@ -4142,7 +4152,7 @@
           <p:cNvPr id="5" name="">
             <a:extLst xmlns:a="http://schemas.openxmlformats.org/drawingml/2006/main">
               <a:ext uri="{FF2B5EF4-FFF2-40B4-BE49-F238E27FC236}">
-                <a16:creationId xmlns:a16="http://schemas.microsoft.com/office/drawing/2014/main" id="{05583098-461E-4E3A-BDE0-6709F273D342}"/>
+                <a16:creationId xmlns:a16="http://schemas.microsoft.com/office/drawing/2014/main" id="{E95F95EC-8302-4EEE-98A8-E0F6964C80F1}"/>
               </a:ext>
             </a:extLst>
           </p:cNvPr>
@@ -4197,7 +4207,7 @@
     </p:spTree>
     <p:extLst>
       <p:ext uri="{BB962C8B-B14F-4D97-AF65-F5344CB8AC3E}">
-        <p14:creationId xmlns:p14="http://schemas.microsoft.com/office/powerpoint/2010/main" val="679640048"/>
+        <p14:creationId xmlns:p14="http://schemas.microsoft.com/office/powerpoint/2010/main" val="329982454"/>
       </p:ext>
     </p:extLst>
   </p:cSld>
@@ -4228,7 +4238,7 @@
           <p:cNvPr id="9" name="">
             <a:extLst xmlns:a="http://schemas.openxmlformats.org/drawingml/2006/main">
               <a:ext uri="{FF2B5EF4-FFF2-40B4-BE49-F238E27FC236}">
-                <a16:creationId xmlns:a16="http://schemas.microsoft.com/office/drawing/2014/main" id="{08024612-2A53-4BFE-A49A-1DEBFB5A0282}"/>
+                <a16:creationId xmlns:a16="http://schemas.microsoft.com/office/drawing/2014/main" id="{FFDDBF3A-D79D-4A34-B78A-0A5D918CCDB0}"/>
               </a:ext>
             </a:extLst>
           </p:cNvPr>
@@ -4285,7 +4295,7 @@
           <p:cNvPr id="2" name="">
             <a:extLst xmlns:a="http://schemas.openxmlformats.org/drawingml/2006/main">
               <a:ext uri="{FF2B5EF4-FFF2-40B4-BE49-F238E27FC236}">
-                <a16:creationId xmlns:a16="http://schemas.microsoft.com/office/drawing/2014/main" id="{BA991586-7B13-4D6C-B979-3FE8A73693FA}"/>
+                <a16:creationId xmlns:a16="http://schemas.microsoft.com/office/drawing/2014/main" id="{3A86AC91-7EDC-4EFE-849F-7CEA68907B9F}"/>
               </a:ext>
             </a:extLst>
           </p:cNvPr>
@@ -4342,7 +4352,7 @@
           <p:cNvPr id="3" name="">
             <a:extLst xmlns:a="http://schemas.openxmlformats.org/drawingml/2006/main">
               <a:ext uri="{FF2B5EF4-FFF2-40B4-BE49-F238E27FC236}">
-                <a16:creationId xmlns:a16="http://schemas.microsoft.com/office/drawing/2014/main" id="{1D40CE60-7CDB-4B3E-AC20-53F708CAD36E}"/>
+                <a16:creationId xmlns:a16="http://schemas.microsoft.com/office/drawing/2014/main" id="{5A2A3418-232A-4A29-8B6D-683549D39D89}"/>
               </a:ext>
             </a:extLst>
           </p:cNvPr>
@@ -4792,7 +4802,7 @@
           <p:cNvPr id="5" name="">
             <a:extLst xmlns:a="http://schemas.openxmlformats.org/drawingml/2006/main">
               <a:ext uri="{FF2B5EF4-FFF2-40B4-BE49-F238E27FC236}">
-                <a16:creationId xmlns:a16="http://schemas.microsoft.com/office/drawing/2014/main" id="{618D7719-CD22-42A6-8697-5D1297FD11AE}"/>
+                <a16:creationId xmlns:a16="http://schemas.microsoft.com/office/drawing/2014/main" id="{834BA0CD-F790-4761-8F12-48AC645062A3}"/>
               </a:ext>
             </a:extLst>
           </p:cNvPr>
@@ -4849,7 +4859,7 @@
           <p:cNvPr id="6" name="">
             <a:extLst xmlns:a="http://schemas.openxmlformats.org/drawingml/2006/main">
               <a:ext uri="{FF2B5EF4-FFF2-40B4-BE49-F238E27FC236}">
-                <a16:creationId xmlns:a16="http://schemas.microsoft.com/office/drawing/2014/main" id="{954C0AD9-0716-4DA8-82F9-FE6FD2277EB5}"/>
+                <a16:creationId xmlns:a16="http://schemas.microsoft.com/office/drawing/2014/main" id="{85640CEC-7EA1-4D30-B88B-5A5C23F432A2}"/>
               </a:ext>
             </a:extLst>
           </p:cNvPr>
@@ -4952,7 +4962,7 @@
           <p:cNvPr id="7" name="">
             <a:extLst xmlns:a="http://schemas.openxmlformats.org/drawingml/2006/main">
               <a:ext uri="{FF2B5EF4-FFF2-40B4-BE49-F238E27FC236}">
-                <a16:creationId xmlns:a16="http://schemas.microsoft.com/office/drawing/2014/main" id="{7A0156BB-B392-4F8F-BDEE-3F7121B1AB24}"/>
+                <a16:creationId xmlns:a16="http://schemas.microsoft.com/office/drawing/2014/main" id="{F1476920-E7D7-4BBF-8357-50C0128258AC}"/>
               </a:ext>
             </a:extLst>
           </p:cNvPr>
@@ -5032,7 +5042,7 @@
           <p:cNvPr id="8" name="">
             <a:extLst xmlns:a="http://schemas.openxmlformats.org/drawingml/2006/main">
               <a:ext uri="{FF2B5EF4-FFF2-40B4-BE49-F238E27FC236}">
-                <a16:creationId xmlns:a16="http://schemas.microsoft.com/office/drawing/2014/main" id="{45C4F497-E7A4-4C61-A2B7-75AD6A52CDDB}"/>
+                <a16:creationId xmlns:a16="http://schemas.microsoft.com/office/drawing/2014/main" id="{C8DA62B5-02C3-44D9-A91D-B7ADCE400679}"/>
               </a:ext>
             </a:extLst>
           </p:cNvPr>
@@ -5087,7 +5097,7 @@
     </p:spTree>
     <p:extLst>
       <p:ext uri="{BB962C8B-B14F-4D97-AF65-F5344CB8AC3E}">
-        <p14:creationId xmlns:p14="http://schemas.microsoft.com/office/powerpoint/2010/main" val="1109030664"/>
+        <p14:creationId xmlns:p14="http://schemas.microsoft.com/office/powerpoint/2010/main" val="1057450484"/>
       </p:ext>
     </p:extLst>
   </p:cSld>
@@ -5118,7 +5128,7 @@
           <p:cNvPr id="10" name="">
             <a:extLst xmlns:a="http://schemas.openxmlformats.org/drawingml/2006/main">
               <a:ext uri="{FF2B5EF4-FFF2-40B4-BE49-F238E27FC236}">
-                <a16:creationId xmlns:a16="http://schemas.microsoft.com/office/drawing/2014/main" id="{0B86C291-92C1-4F4F-A2AB-B602D0ADED6A}"/>
+                <a16:creationId xmlns:a16="http://schemas.microsoft.com/office/drawing/2014/main" id="{22D13D26-4285-43FF-AA53-4572852D000F}"/>
               </a:ext>
             </a:extLst>
           </p:cNvPr>
@@ -5175,7 +5185,7 @@
           <p:cNvPr id="2" name="">
             <a:extLst xmlns:a="http://schemas.openxmlformats.org/drawingml/2006/main">
               <a:ext uri="{FF2B5EF4-FFF2-40B4-BE49-F238E27FC236}">
-                <a16:creationId xmlns:a16="http://schemas.microsoft.com/office/drawing/2014/main" id="{C5896D04-17E1-4672-90FA-34644F2062E6}"/>
+                <a16:creationId xmlns:a16="http://schemas.microsoft.com/office/drawing/2014/main" id="{2AF52471-E4B3-457A-85BA-E4F694D6AB7E}"/>
               </a:ext>
             </a:extLst>
           </p:cNvPr>
@@ -5232,7 +5242,7 @@
           <p:cNvPr id="3" name="">
             <a:extLst xmlns:a="http://schemas.openxmlformats.org/drawingml/2006/main">
               <a:ext uri="{FF2B5EF4-FFF2-40B4-BE49-F238E27FC236}">
-                <a16:creationId xmlns:a16="http://schemas.microsoft.com/office/drawing/2014/main" id="{E0E67DFF-F08D-4C06-8479-A69BC5F19843}"/>
+                <a16:creationId xmlns:a16="http://schemas.microsoft.com/office/drawing/2014/main" id="{7C803B32-EC57-4C7A-87C8-7AA2187E53CA}"/>
               </a:ext>
             </a:extLst>
           </p:cNvPr>
@@ -5289,7 +5299,7 @@
           <p:cNvPr id="4" name="">
             <a:extLst xmlns:a="http://schemas.openxmlformats.org/drawingml/2006/main">
               <a:ext uri="{FF2B5EF4-FFF2-40B4-BE49-F238E27FC236}">
-                <a16:creationId xmlns:a16="http://schemas.microsoft.com/office/drawing/2014/main" id="{738E7479-4B86-46BD-9092-990187B88631}"/>
+                <a16:creationId xmlns:a16="http://schemas.microsoft.com/office/drawing/2014/main" id="{13293C87-0807-444E-A676-554402C5BF91}"/>
               </a:ext>
             </a:extLst>
           </p:cNvPr>
@@ -5346,7 +5356,7 @@
           <p:cNvPr id="5" name="">
             <a:extLst xmlns:a="http://schemas.openxmlformats.org/drawingml/2006/main">
               <a:ext uri="{FF2B5EF4-FFF2-40B4-BE49-F238E27FC236}">
-                <a16:creationId xmlns:a16="http://schemas.microsoft.com/office/drawing/2014/main" id="{060D217C-465D-4354-9CBD-2B62A1BB182C}"/>
+                <a16:creationId xmlns:a16="http://schemas.microsoft.com/office/drawing/2014/main" id="{600B1765-23B1-424F-8678-0EBE1B3ACC32}"/>
               </a:ext>
             </a:extLst>
           </p:cNvPr>
@@ -5426,7 +5436,7 @@
           <p:cNvPr id="6" name="">
             <a:extLst xmlns:a="http://schemas.openxmlformats.org/drawingml/2006/main">
               <a:ext uri="{FF2B5EF4-FFF2-40B4-BE49-F238E27FC236}">
-                <a16:creationId xmlns:a16="http://schemas.microsoft.com/office/drawing/2014/main" id="{1687837E-E63C-47CC-B189-637E91193D7C}"/>
+                <a16:creationId xmlns:a16="http://schemas.microsoft.com/office/drawing/2014/main" id="{F2F5112D-DCE6-4A5A-892B-97F562FFE809}"/>
               </a:ext>
             </a:extLst>
           </p:cNvPr>
@@ -5506,7 +5516,7 @@
           <p:cNvPr id="7" name="">
             <a:extLst xmlns:a="http://schemas.openxmlformats.org/drawingml/2006/main">
               <a:ext uri="{FF2B5EF4-FFF2-40B4-BE49-F238E27FC236}">
-                <a16:creationId xmlns:a16="http://schemas.microsoft.com/office/drawing/2014/main" id="{F3FAC0BD-AEBD-4BF3-A8A9-0F463B62A5CA}"/>
+                <a16:creationId xmlns:a16="http://schemas.microsoft.com/office/drawing/2014/main" id="{37606950-BD29-40F5-AA6D-F432EEB32957}"/>
               </a:ext>
             </a:extLst>
           </p:cNvPr>
@@ -5563,7 +5573,7 @@
           <p:cNvPr id="8" name="">
             <a:extLst xmlns:a="http://schemas.openxmlformats.org/drawingml/2006/main">
               <a:ext uri="{FF2B5EF4-FFF2-40B4-BE49-F238E27FC236}">
-                <a16:creationId xmlns:a16="http://schemas.microsoft.com/office/drawing/2014/main" id="{BB491A51-AC08-4029-BDC5-15527A9A0277}"/>
+                <a16:creationId xmlns:a16="http://schemas.microsoft.com/office/drawing/2014/main" id="{FCBC2FB5-44CF-4341-8E60-7A17CB17756B}"/>
               </a:ext>
             </a:extLst>
           </p:cNvPr>
@@ -5676,7 +5686,7 @@
           <p:cNvPr id="9" name="">
             <a:extLst xmlns:a="http://schemas.openxmlformats.org/drawingml/2006/main">
               <a:ext uri="{FF2B5EF4-FFF2-40B4-BE49-F238E27FC236}">
-                <a16:creationId xmlns:a16="http://schemas.microsoft.com/office/drawing/2014/main" id="{A254BC3A-2102-431A-A0AD-4E583AB2871D}"/>
+                <a16:creationId xmlns:a16="http://schemas.microsoft.com/office/drawing/2014/main" id="{C1FDCB79-36AA-4481-A89D-F51333CB1B81}"/>
               </a:ext>
             </a:extLst>
           </p:cNvPr>
@@ -5731,7 +5741,7 @@
     </p:spTree>
     <p:extLst>
       <p:ext uri="{BB962C8B-B14F-4D97-AF65-F5344CB8AC3E}">
-        <p14:creationId xmlns:p14="http://schemas.microsoft.com/office/powerpoint/2010/main" val="1390335087"/>
+        <p14:creationId xmlns:p14="http://schemas.microsoft.com/office/powerpoint/2010/main" val="1380762621"/>
       </p:ext>
     </p:extLst>
   </p:cSld>
@@ -5762,7 +5772,7 @@
           <p:cNvPr id="11" name="">
             <a:extLst xmlns:a="http://schemas.openxmlformats.org/drawingml/2006/main">
               <a:ext uri="{FF2B5EF4-FFF2-40B4-BE49-F238E27FC236}">
-                <a16:creationId xmlns:a16="http://schemas.microsoft.com/office/drawing/2014/main" id="{8FD68DCA-31CD-4E59-A7FE-38AA77EB8CB8}"/>
+                <a16:creationId xmlns:a16="http://schemas.microsoft.com/office/drawing/2014/main" id="{7A954BAE-B049-468B-86E2-D24F89552553}"/>
               </a:ext>
             </a:extLst>
           </p:cNvPr>
@@ -5819,7 +5829,7 @@
           <p:cNvPr id="2" name="">
             <a:extLst xmlns:a="http://schemas.openxmlformats.org/drawingml/2006/main">
               <a:ext uri="{FF2B5EF4-FFF2-40B4-BE49-F238E27FC236}">
-                <a16:creationId xmlns:a16="http://schemas.microsoft.com/office/drawing/2014/main" id="{04612CB9-5FDC-4D7B-880E-03005CDA07B4}"/>
+                <a16:creationId xmlns:a16="http://schemas.microsoft.com/office/drawing/2014/main" id="{449D633A-D009-42DE-B40A-FAA8B88BA4F3}"/>
               </a:ext>
             </a:extLst>
           </p:cNvPr>
@@ -5876,7 +5886,7 @@
           <p:cNvPr id="3" name="">
             <a:extLst xmlns:a="http://schemas.openxmlformats.org/drawingml/2006/main">
               <a:ext uri="{FF2B5EF4-FFF2-40B4-BE49-F238E27FC236}">
-                <a16:creationId xmlns:a16="http://schemas.microsoft.com/office/drawing/2014/main" id="{AF1180AB-BADB-445D-BA4A-8523C8BB9E2E}"/>
+                <a16:creationId xmlns:a16="http://schemas.microsoft.com/office/drawing/2014/main" id="{6FE22AC0-882E-44D4-9045-EE26981BCD5E}"/>
               </a:ext>
             </a:extLst>
           </p:cNvPr>
@@ -5933,7 +5943,7 @@
           <p:cNvPr id="4" name="">
             <a:extLst xmlns:a="http://schemas.openxmlformats.org/drawingml/2006/main">
               <a:ext uri="{FF2B5EF4-FFF2-40B4-BE49-F238E27FC236}">
-                <a16:creationId xmlns:a16="http://schemas.microsoft.com/office/drawing/2014/main" id="{E0DB47CD-7859-4605-897F-9D6817C98730}"/>
+                <a16:creationId xmlns:a16="http://schemas.microsoft.com/office/drawing/2014/main" id="{BAC78DB7-F8A3-4DA2-9D26-7C3E5ECCED51}"/>
               </a:ext>
             </a:extLst>
           </p:cNvPr>
@@ -5990,7 +6000,7 @@
           <p:cNvPr id="5" name="">
             <a:extLst xmlns:a="http://schemas.openxmlformats.org/drawingml/2006/main">
               <a:ext uri="{FF2B5EF4-FFF2-40B4-BE49-F238E27FC236}">
-                <a16:creationId xmlns:a16="http://schemas.microsoft.com/office/drawing/2014/main" id="{133E02D4-134F-4804-AF57-53020351E146}"/>
+                <a16:creationId xmlns:a16="http://schemas.microsoft.com/office/drawing/2014/main" id="{A1B5F498-00B2-4D69-BBAE-A40833EED6C4}"/>
               </a:ext>
             </a:extLst>
           </p:cNvPr>
@@ -6070,7 +6080,7 @@
           <p:cNvPr id="6" name="">
             <a:extLst xmlns:a="http://schemas.openxmlformats.org/drawingml/2006/main">
               <a:ext uri="{FF2B5EF4-FFF2-40B4-BE49-F238E27FC236}">
-                <a16:creationId xmlns:a16="http://schemas.microsoft.com/office/drawing/2014/main" id="{20F01F33-A071-4B49-8AA2-3BB1E69D02F5}"/>
+                <a16:creationId xmlns:a16="http://schemas.microsoft.com/office/drawing/2014/main" id="{30A99C85-15D3-4373-A298-CEC0258BC439}"/>
               </a:ext>
             </a:extLst>
           </p:cNvPr>
@@ -6127,7 +6137,7 @@
           <p:cNvPr id="7" name="">
             <a:extLst xmlns:a="http://schemas.openxmlformats.org/drawingml/2006/main">
               <a:ext uri="{FF2B5EF4-FFF2-40B4-BE49-F238E27FC236}">
-                <a16:creationId xmlns:a16="http://schemas.microsoft.com/office/drawing/2014/main" id="{ADBEF901-F5B4-484F-8C01-441BABE34442}"/>
+                <a16:creationId xmlns:a16="http://schemas.microsoft.com/office/drawing/2014/main" id="{2FF75C5F-4E11-4898-A337-A6DADECFFC86}"/>
               </a:ext>
             </a:extLst>
           </p:cNvPr>
@@ -6184,7 +6194,7 @@
           <p:cNvPr id="8" name="">
             <a:extLst xmlns:a="http://schemas.openxmlformats.org/drawingml/2006/main">
               <a:ext uri="{FF2B5EF4-FFF2-40B4-BE49-F238E27FC236}">
-                <a16:creationId xmlns:a16="http://schemas.microsoft.com/office/drawing/2014/main" id="{334B0C3E-0078-42BC-BC85-918AAE51BDAC}"/>
+                <a16:creationId xmlns:a16="http://schemas.microsoft.com/office/drawing/2014/main" id="{9C580237-884F-4BF8-A3E6-596D38C4AF69}"/>
               </a:ext>
             </a:extLst>
           </p:cNvPr>
@@ -6342,7 +6352,7 @@
                           <a:ea typeface="Avenir"/>
                           <a:cs typeface="Avenir"/>
                         </a:rPr>
-                        <a:t>ECRI: alerts and workflow</a:t>
+                        <a:t>Staritas (formerly ECRI)</a:t>
                       </a:r>
                     </a:p>
                   </a:txBody>
@@ -6486,7 +6496,7 @@
           <p:cNvPr id="10" name="">
             <a:extLst xmlns:a="http://schemas.openxmlformats.org/drawingml/2006/main">
               <a:ext uri="{FF2B5EF4-FFF2-40B4-BE49-F238E27FC236}">
-                <a16:creationId xmlns:a16="http://schemas.microsoft.com/office/drawing/2014/main" id="{40C9DD99-92F8-4155-87B2-D167E3C88067}"/>
+                <a16:creationId xmlns:a16="http://schemas.microsoft.com/office/drawing/2014/main" id="{6B0F3AFC-81AE-49CD-8EF4-C1A98CEE812B}"/>
               </a:ext>
             </a:extLst>
           </p:cNvPr>
@@ -6543,7 +6553,30 @@
                 <a:latin typeface="Avenir"/>
                 <a:ea typeface="Avenir"/>
                 <a:cs typeface="Avenir"/>
-                <a:hlinkClick xmlns:r="http://schemas.openxmlformats.org/officeDocument/2006/relationships" r:id="R137e669f23334a41"/>
+                <a:hlinkClick xmlns:r="http://schemas.openxmlformats.org/officeDocument/2006/relationships" r:id="R14b6d5a53a2343ab"/>
+              </a:rPr>
+              <a:t>Staritas</a:t>
+            </a:r>
+            <a:r>
+              <a:rPr sz="1200" b="0">
+                <a:solidFill>
+                  <a:srgbClr val="56707B"/>
+                </a:solidFill>
+                <a:latin typeface="Avenir"/>
+                <a:ea typeface="Avenir"/>
+                <a:cs typeface="Avenir"/>
+              </a:rPr>
+              <a:t> (formerly </a:t>
+            </a:r>
+            <a:r>
+              <a:rPr sz="1200" b="0">
+                <a:solidFill>
+                  <a:srgbClr val="56707B"/>
+                </a:solidFill>
+                <a:latin typeface="Avenir"/>
+                <a:ea typeface="Avenir"/>
+                <a:cs typeface="Avenir"/>
+                <a:hlinkClick xmlns:r="http://schemas.openxmlformats.org/officeDocument/2006/relationships" r:id="R86124f0168f94453"/>
               </a:rPr>
               <a:t>ECRI</a:t>
             </a:r>
@@ -6556,7 +6589,7 @@
                 <a:ea typeface="Avenir"/>
                 <a:cs typeface="Avenir"/>
               </a:rPr>
-              <a:t> and </a:t>
+              <a:t>) and </a:t>
             </a:r>
             <a:r>
               <a:rPr sz="1200" b="0">
@@ -6566,7 +6599,7 @@
                 <a:latin typeface="Avenir"/>
                 <a:ea typeface="Avenir"/>
                 <a:cs typeface="Avenir"/>
-                <a:hlinkClick xmlns:r="http://schemas.openxmlformats.org/officeDocument/2006/relationships" r:id="R56f36dc7ded44d45"/>
+                <a:hlinkClick xmlns:r="http://schemas.openxmlformats.org/officeDocument/2006/relationships" r:id="R9f6f499306ee4c78"/>
               </a:rPr>
               <a:t>GHX</a:t>
             </a:r>
@@ -6579,7 +6612,7 @@
                 <a:ea typeface="Avenir"/>
                 <a:cs typeface="Avenir"/>
               </a:rPr>
-              <a:t> product descriptions. Proposed pricing only. No customers, revenue or partnerships claimed.</a:t>
+              <a:t>. Proposed pricing only. No customers, revenue or partnerships claimed.</a:t>
             </a:r>
           </a:p>
         </p:txBody>
@@ -6587,7 +6620,7 @@
     </p:spTree>
     <p:extLst>
       <p:ext uri="{BB962C8B-B14F-4D97-AF65-F5344CB8AC3E}">
-        <p14:creationId xmlns:p14="http://schemas.microsoft.com/office/powerpoint/2010/main" val="496439834"/>
+        <p14:creationId xmlns:p14="http://schemas.microsoft.com/office/powerpoint/2010/main" val="1811667212"/>
       </p:ext>
     </p:extLst>
   </p:cSld>
@@ -6618,7 +6651,7 @@
           <p:cNvPr id="9" name="">
             <a:extLst xmlns:a="http://schemas.openxmlformats.org/drawingml/2006/main">
               <a:ext uri="{FF2B5EF4-FFF2-40B4-BE49-F238E27FC236}">
-                <a16:creationId xmlns:a16="http://schemas.microsoft.com/office/drawing/2014/main" id="{1C464D71-FE8A-46FE-A852-12FA361C1746}"/>
+                <a16:creationId xmlns:a16="http://schemas.microsoft.com/office/drawing/2014/main" id="{B8582BEB-3616-4F1F-8081-62B6ED1BD6C8}"/>
               </a:ext>
             </a:extLst>
           </p:cNvPr>
@@ -6675,7 +6708,7 @@
           <p:cNvPr id="2" name="">
             <a:extLst xmlns:a="http://schemas.openxmlformats.org/drawingml/2006/main">
               <a:ext uri="{FF2B5EF4-FFF2-40B4-BE49-F238E27FC236}">
-                <a16:creationId xmlns:a16="http://schemas.microsoft.com/office/drawing/2014/main" id="{B882A268-EDDD-4103-9373-92B52A9A1097}"/>
+                <a16:creationId xmlns:a16="http://schemas.microsoft.com/office/drawing/2014/main" id="{6D8ADDFF-671D-4FFE-A6D7-D69AA6ADDB8A}"/>
               </a:ext>
             </a:extLst>
           </p:cNvPr>
@@ -6732,7 +6765,7 @@
           <p:cNvPr id="3" name="">
             <a:extLst xmlns:a="http://schemas.openxmlformats.org/drawingml/2006/main">
               <a:ext uri="{FF2B5EF4-FFF2-40B4-BE49-F238E27FC236}">
-                <a16:creationId xmlns:a16="http://schemas.microsoft.com/office/drawing/2014/main" id="{AABC8B28-231E-419F-AB18-7252877C591C}"/>
+                <a16:creationId xmlns:a16="http://schemas.microsoft.com/office/drawing/2014/main" id="{333E9BA5-451A-471A-902E-852E4270E6DA}"/>
               </a:ext>
             </a:extLst>
           </p:cNvPr>
@@ -6789,7 +6822,7 @@
           <p:cNvPr id="4" name="">
             <a:extLst xmlns:a="http://schemas.openxmlformats.org/drawingml/2006/main">
               <a:ext uri="{FF2B5EF4-FFF2-40B4-BE49-F238E27FC236}">
-                <a16:creationId xmlns:a16="http://schemas.microsoft.com/office/drawing/2014/main" id="{98943FF1-25F0-4639-B99F-9F7F38140E18}"/>
+                <a16:creationId xmlns:a16="http://schemas.microsoft.com/office/drawing/2014/main" id="{90C2B4DB-5FAE-4907-BE03-EE292DC474E2}"/>
               </a:ext>
             </a:extLst>
           </p:cNvPr>
@@ -6846,7 +6879,7 @@
           <p:cNvPr id="5" name="">
             <a:extLst xmlns:a="http://schemas.openxmlformats.org/drawingml/2006/main">
               <a:ext uri="{FF2B5EF4-FFF2-40B4-BE49-F238E27FC236}">
-                <a16:creationId xmlns:a16="http://schemas.microsoft.com/office/drawing/2014/main" id="{535D482F-3C8B-4389-B0E2-4AF4770EA8C2}"/>
+                <a16:creationId xmlns:a16="http://schemas.microsoft.com/office/drawing/2014/main" id="{BA95BBEB-9097-48EE-8D3C-0493DBF1DAB5}"/>
               </a:ext>
             </a:extLst>
           </p:cNvPr>
@@ -6995,7 +7028,7 @@
           <p:cNvPr id="6" name="">
             <a:extLst xmlns:a="http://schemas.openxmlformats.org/drawingml/2006/main">
               <a:ext uri="{FF2B5EF4-FFF2-40B4-BE49-F238E27FC236}">
-                <a16:creationId xmlns:a16="http://schemas.microsoft.com/office/drawing/2014/main" id="{C84EB8CD-E87B-4C7F-810A-78DA27DF55C7}"/>
+                <a16:creationId xmlns:a16="http://schemas.microsoft.com/office/drawing/2014/main" id="{1535B685-B786-4668-98F1-C3F050AE0070}"/>
               </a:ext>
             </a:extLst>
           </p:cNvPr>
@@ -7052,7 +7085,7 @@
           <p:cNvPr id="7" name="">
             <a:extLst xmlns:a="http://schemas.openxmlformats.org/drawingml/2006/main">
               <a:ext uri="{FF2B5EF4-FFF2-40B4-BE49-F238E27FC236}">
-                <a16:creationId xmlns:a16="http://schemas.microsoft.com/office/drawing/2014/main" id="{B8C83831-A81E-4E6B-83A6-BA95CA387F62}"/>
+                <a16:creationId xmlns:a16="http://schemas.microsoft.com/office/drawing/2014/main" id="{EC8B7F04-0598-4E6B-A71F-1E7228374176}"/>
               </a:ext>
             </a:extLst>
           </p:cNvPr>
@@ -7201,7 +7234,7 @@
           <p:cNvPr id="8" name="">
             <a:extLst xmlns:a="http://schemas.openxmlformats.org/drawingml/2006/main">
               <a:ext uri="{FF2B5EF4-FFF2-40B4-BE49-F238E27FC236}">
-                <a16:creationId xmlns:a16="http://schemas.microsoft.com/office/drawing/2014/main" id="{1012C8E2-F40A-4D5A-9961-DCD5D7A85FC8}"/>
+                <a16:creationId xmlns:a16="http://schemas.microsoft.com/office/drawing/2014/main" id="{DD795C53-6951-413A-9A69-81EE3528CED4}"/>
               </a:ext>
             </a:extLst>
           </p:cNvPr>
@@ -7256,7 +7289,7 @@
     </p:spTree>
     <p:extLst>
       <p:ext uri="{BB962C8B-B14F-4D97-AF65-F5344CB8AC3E}">
-        <p14:creationId xmlns:p14="http://schemas.microsoft.com/office/powerpoint/2010/main" val="1574446372"/>
+        <p14:creationId xmlns:p14="http://schemas.microsoft.com/office/powerpoint/2010/main" val="59033972"/>
       </p:ext>
     </p:extLst>
   </p:cSld>
@@ -7287,7 +7320,7 @@
           <p:cNvPr id="9" name="">
             <a:extLst xmlns:a="http://schemas.openxmlformats.org/drawingml/2006/main">
               <a:ext uri="{FF2B5EF4-FFF2-40B4-BE49-F238E27FC236}">
-                <a16:creationId xmlns:a16="http://schemas.microsoft.com/office/drawing/2014/main" id="{1F469871-4EAC-4E3A-91FE-A8C9CC2851C4}"/>
+                <a16:creationId xmlns:a16="http://schemas.microsoft.com/office/drawing/2014/main" id="{2E48BB85-C1E0-40E3-9B20-3827CF21FDC2}"/>
               </a:ext>
             </a:extLst>
           </p:cNvPr>
@@ -7344,7 +7377,7 @@
           <p:cNvPr id="2" name="">
             <a:extLst xmlns:a="http://schemas.openxmlformats.org/drawingml/2006/main">
               <a:ext uri="{FF2B5EF4-FFF2-40B4-BE49-F238E27FC236}">
-                <a16:creationId xmlns:a16="http://schemas.microsoft.com/office/drawing/2014/main" id="{A6948404-799B-423E-B50A-BCB6D933AA15}"/>
+                <a16:creationId xmlns:a16="http://schemas.microsoft.com/office/drawing/2014/main" id="{2E582C3B-39FD-473B-8765-6C040234590A}"/>
               </a:ext>
             </a:extLst>
           </p:cNvPr>
@@ -7401,7 +7434,7 @@
           <p:cNvPr id="3" name="">
             <a:extLst xmlns:a="http://schemas.openxmlformats.org/drawingml/2006/main">
               <a:ext uri="{FF2B5EF4-FFF2-40B4-BE49-F238E27FC236}">
-                <a16:creationId xmlns:a16="http://schemas.microsoft.com/office/drawing/2014/main" id="{A3640D34-9059-4279-B53E-30A00A222F2D}"/>
+                <a16:creationId xmlns:a16="http://schemas.microsoft.com/office/drawing/2014/main" id="{F77553D9-BDC2-4C43-B05A-588AD3B530ED}"/>
               </a:ext>
             </a:extLst>
           </p:cNvPr>
@@ -7458,7 +7491,7 @@
           <p:cNvPr id="4" name="">
             <a:extLst xmlns:a="http://schemas.openxmlformats.org/drawingml/2006/main">
               <a:ext uri="{FF2B5EF4-FFF2-40B4-BE49-F238E27FC236}">
-                <a16:creationId xmlns:a16="http://schemas.microsoft.com/office/drawing/2014/main" id="{949380CB-44EE-488D-8A27-B6FFF3F423AF}"/>
+                <a16:creationId xmlns:a16="http://schemas.microsoft.com/office/drawing/2014/main" id="{79175849-A5C9-4B86-A566-D06B0DD93A62}"/>
               </a:ext>
             </a:extLst>
           </p:cNvPr>
@@ -7515,7 +7548,7 @@
           <p:cNvPr id="5" name="">
             <a:extLst xmlns:a="http://schemas.openxmlformats.org/drawingml/2006/main">
               <a:ext uri="{FF2B5EF4-FFF2-40B4-BE49-F238E27FC236}">
-                <a16:creationId xmlns:a16="http://schemas.microsoft.com/office/drawing/2014/main" id="{CD4339D0-ED90-4950-B7CD-3090E6372684}"/>
+                <a16:creationId xmlns:a16="http://schemas.microsoft.com/office/drawing/2014/main" id="{246F2E9A-851C-4292-BEE4-6640528858E1}"/>
               </a:ext>
             </a:extLst>
           </p:cNvPr>
@@ -7595,7 +7628,7 @@
           <p:cNvPr id="6" name="">
             <a:extLst xmlns:a="http://schemas.openxmlformats.org/drawingml/2006/main">
               <a:ext uri="{FF2B5EF4-FFF2-40B4-BE49-F238E27FC236}">
-                <a16:creationId xmlns:a16="http://schemas.microsoft.com/office/drawing/2014/main" id="{82521849-C395-4A7B-A8E9-30B6CD40671A}"/>
+                <a16:creationId xmlns:a16="http://schemas.microsoft.com/office/drawing/2014/main" id="{04E19BAD-1C9E-458C-AB34-EC61572D8C37}"/>
               </a:ext>
             </a:extLst>
           </p:cNvPr>
@@ -7652,7 +7685,7 @@
           <p:cNvPr id="7" name="">
             <a:extLst xmlns:a="http://schemas.openxmlformats.org/drawingml/2006/main">
               <a:ext uri="{FF2B5EF4-FFF2-40B4-BE49-F238E27FC236}">
-                <a16:creationId xmlns:a16="http://schemas.microsoft.com/office/drawing/2014/main" id="{69152468-BACF-46AF-8A66-328715BFAC97}"/>
+                <a16:creationId xmlns:a16="http://schemas.microsoft.com/office/drawing/2014/main" id="{71FCC25E-0D1D-46CB-A8C5-C08DC5688242}"/>
               </a:ext>
             </a:extLst>
           </p:cNvPr>
@@ -7788,7 +7821,7 @@
           <p:cNvPr id="8" name="">
             <a:extLst xmlns:a="http://schemas.openxmlformats.org/drawingml/2006/main">
               <a:ext uri="{FF2B5EF4-FFF2-40B4-BE49-F238E27FC236}">
-                <a16:creationId xmlns:a16="http://schemas.microsoft.com/office/drawing/2014/main" id="{4B97FD89-42EC-4D8B-AF55-DA5FB9351FF9}"/>
+                <a16:creationId xmlns:a16="http://schemas.microsoft.com/office/drawing/2014/main" id="{89985509-9A14-43E9-9573-4A15C9A98F7D}"/>
               </a:ext>
             </a:extLst>
           </p:cNvPr>
@@ -7843,7 +7876,7 @@
     </p:spTree>
     <p:extLst>
       <p:ext uri="{BB962C8B-B14F-4D97-AF65-F5344CB8AC3E}">
-        <p14:creationId xmlns:p14="http://schemas.microsoft.com/office/powerpoint/2010/main" val="113651085"/>
+        <p14:creationId xmlns:p14="http://schemas.microsoft.com/office/powerpoint/2010/main" val="1794745860"/>
       </p:ext>
     </p:extLst>
   </p:cSld>

</xml_diff>